<commit_message>
feat(stage17): bind contest evidence and align product claims
</commit_message>
<xml_diff>
--- a/docs/contest/Porukam-pitch.pptx
+++ b/docs/contest/Porukam-pitch.pptx
@@ -2,20 +2,20 @@
 <file path=ppt/presentation.xml><?xml version="1.0" encoding="utf-8"?>
 <p:presentation xmlns:p="http://schemas.openxmlformats.org/presentationml/2006/main">
   <p:sldMasterIdLst>
-    <p:sldMasterId xmlns:r="http://schemas.openxmlformats.org/officeDocument/2006/relationships" id="2147483648" r:id="Rd989b7e1dc804135"/>
+    <p:sldMasterId xmlns:r="http://schemas.openxmlformats.org/officeDocument/2006/relationships" id="2147483648" r:id="R631e72ff7ce743c4"/>
   </p:sldMasterIdLst>
   <p:notesMasterIdLst>
-    <p:notesMasterId xmlns:r="http://schemas.openxmlformats.org/officeDocument/2006/relationships" r:id="Rff7a7506c7054242"/>
+    <p:notesMasterId xmlns:r="http://schemas.openxmlformats.org/officeDocument/2006/relationships" r:id="R211574459d7d4097"/>
   </p:notesMasterIdLst>
   <p:sldIdLst>
-    <p:sldId xmlns:r="http://schemas.openxmlformats.org/officeDocument/2006/relationships" id="256" r:id="Rd57f75d1d0014f8c"/>
-    <p:sldId xmlns:r="http://schemas.openxmlformats.org/officeDocument/2006/relationships" id="257" r:id="R66ff663575a547cb"/>
-    <p:sldId xmlns:r="http://schemas.openxmlformats.org/officeDocument/2006/relationships" id="258" r:id="R3a5b521dd5f04335"/>
-    <p:sldId xmlns:r="http://schemas.openxmlformats.org/officeDocument/2006/relationships" id="259" r:id="R63ced45f32534726"/>
-    <p:sldId xmlns:r="http://schemas.openxmlformats.org/officeDocument/2006/relationships" id="260" r:id="R29ab0d60e39f4969"/>
-    <p:sldId xmlns:r="http://schemas.openxmlformats.org/officeDocument/2006/relationships" id="261" r:id="R46aee827de784811"/>
-    <p:sldId xmlns:r="http://schemas.openxmlformats.org/officeDocument/2006/relationships" id="262" r:id="R94c9965a0b134932"/>
-    <p:sldId xmlns:r="http://schemas.openxmlformats.org/officeDocument/2006/relationships" id="263" r:id="R894841950ae84d92"/>
+    <p:sldId xmlns:r="http://schemas.openxmlformats.org/officeDocument/2006/relationships" id="256" r:id="R4f9a8c75693a449b"/>
+    <p:sldId xmlns:r="http://schemas.openxmlformats.org/officeDocument/2006/relationships" id="257" r:id="R2dc864aa2a534a0c"/>
+    <p:sldId xmlns:r="http://schemas.openxmlformats.org/officeDocument/2006/relationships" id="258" r:id="Rc63ae164a2f149d8"/>
+    <p:sldId xmlns:r="http://schemas.openxmlformats.org/officeDocument/2006/relationships" id="259" r:id="R859407d2202b4d87"/>
+    <p:sldId xmlns:r="http://schemas.openxmlformats.org/officeDocument/2006/relationships" id="260" r:id="Rbc2d254673754a7a"/>
+    <p:sldId xmlns:r="http://schemas.openxmlformats.org/officeDocument/2006/relationships" id="261" r:id="R78759712a497451c"/>
+    <p:sldId xmlns:r="http://schemas.openxmlformats.org/officeDocument/2006/relationships" id="262" r:id="Rf2c3d80dd30c47c7"/>
+    <p:sldId xmlns:r="http://schemas.openxmlformats.org/officeDocument/2006/relationships" id="263" r:id="R08db53f0c03b439b"/>
   </p:sldIdLst>
   <p:sldSz cx="12192000" cy="6858000"/>
   <p:notesSz cx="6858000" cy="9144000"/>
@@ -447,7 +447,11 @@
         <p:txBody>
           <a:bodyPr xmlns:a="http://schemas.openxmlformats.org/drawingml/2006/main"/>
           <a:lstStyle xmlns:a="http://schemas.openxmlformats.org/drawingml/2006/main"/>
-          <a:p xmlns:a="http://schemas.openxmlformats.org/drawingml/2006/main"/>
+          <a:p xmlns:a="http://schemas.openxmlformats.org/drawingml/2006/main">
+            <a:r>
+              <a:t>Источники: NEXT_STEPS.md, этапы S15/S16/S17; docs/analysis/stage-16.md. Продукт для российских компаний, расчёты RUB. Предложение не гарантирует заказ. Все примеры и компании синтетические. База ревью S17: main 4b7730b.</a:t>
+            </a:r>
+          </a:p>
         </p:txBody>
       </p:sp>
       <p:sp>
@@ -513,7 +517,11 @@
         <p:txBody>
           <a:bodyPr xmlns:a="http://schemas.openxmlformats.org/drawingml/2006/main"/>
           <a:lstStyle xmlns:a="http://schemas.openxmlformats.org/drawingml/2006/main"/>
-          <a:p xmlns:a="http://schemas.openxmlformats.org/drawingml/2006/main"/>
+          <a:p xmlns:a="http://schemas.openxmlformats.org/drawingml/2006/main">
+            <a:r>
+              <a:t>Источник: docs/analysis/stage-16.md, таблицы категорий и B01–B13. 12 разделов и 47 листьев — классификация. Это не число готовых коммерческих направлений. Постоянный поставщик, таблица и прямое КП сохраняют ценность.</a:t>
+            </a:r>
+          </a:p>
         </p:txBody>
       </p:sp>
       <p:sp>
@@ -579,7 +587,11 @@
         <p:txBody>
           <a:bodyPr xmlns:a="http://schemas.openxmlformats.org/drawingml/2006/main"/>
           <a:lstStyle xmlns:a="http://schemas.openxmlformats.org/drawingml/2006/main"/>
-          <a:p xmlns:a="http://schemas.openxmlformats.org/drawingml/2006/main"/>
+          <a:p xmlns:a="http://schemas.openxmlformats.org/drawingml/2006/main">
+            <a:r>
+              <a:t>Источники: docs/analysis/stage-16.md, B01–B05/B13 и расчётный контракт business-analysis-1; NEXT_STEPS.md S03–S05/S08. Выгода требует сопоставимой спецификации, объёма, единицы, налоговой базы, адреса и срока. Неизвестные данные сохраняются, коалиция не гарантирует исполнение.</a:t>
+            </a:r>
+          </a:p>
         </p:txBody>
       </p:sp>
       <p:sp>
@@ -645,7 +657,11 @@
         <p:txBody>
           <a:bodyPr xmlns:a="http://schemas.openxmlformats.org/drawingml/2006/main"/>
           <a:lstStyle xmlns:a="http://schemas.openxmlformats.org/drawingml/2006/main"/>
-          <a:p xmlns:a="http://schemas.openxmlformats.org/drawingml/2006/main"/>
+          <a:p xmlns:a="http://schemas.openxmlformats.org/drawingml/2006/main">
+            <a:r>
+              <a:t>Источник: docs/analysis/stage-16.md, B05/B07–B13 и решения S16.04; NEXT_STEPS.md S08–S12. Черновик КП не означает отправку. Активный труд включает ввод, правки, повтор и обучение. Непокрытый объём и стоимость резерва сохраняются. Гарантия экономии, прибыли и загрузки мощности отсутствует.</a:t>
+            </a:r>
+          </a:p>
         </p:txBody>
       </p:sp>
       <p:sp>
@@ -711,7 +727,11 @@
         <p:txBody>
           <a:bodyPr xmlns:a="http://schemas.openxmlformats.org/drawingml/2006/main"/>
           <a:lstStyle xmlns:a="http://schemas.openxmlformats.org/drawingml/2006/main"/>
-          <a:p xmlns:a="http://schemas.openxmlformats.org/drawingml/2006/main"/>
+          <a:p xmlns:a="http://schemas.openxmlformats.org/drawingml/2006/main">
+            <a:r>
+              <a:t>Источники: NEXT_STEPS.md S15.01 и таблица доказательств S15; docs/analysis/stage-16.md, раздел всех направлений. 9 рабочих синтетических листьев: коробки, пакеты, плёнка, крепёж, спецодежда, текстиль, мебель, отделочные материалы, компоненты. 46 поддерживаемых предметных профилей и 1 unsupported — медицинские расходники. Паспорта остальных листьев не равны сквозной коммерческой приёмке.</a:t>
+            </a:r>
+          </a:p>
         </p:txBody>
       </p:sp>
       <p:sp>
@@ -777,7 +797,11 @@
         <p:txBody>
           <a:bodyPr xmlns:a="http://schemas.openxmlformats.org/drawingml/2006/main"/>
           <a:lstStyle xmlns:a="http://schemas.openxmlformats.org/drawingml/2006/main"/>
-          <a:p xmlns:a="http://schemas.openxmlformats.org/drawingml/2006/main"/>
+          <a:p xmlns:a="http://schemas.openxmlformats.org/drawingml/2006/main">
+            <a:r>
+              <a:t>Источники: docs/operations/stage-15.md, версии/безопасный запуск, локальная сеть и пределы; NEXT_STEPS.md S03/S06/S15; docs/analysis/stage-16.md B07/B13. Локальная LLM вызывается только через Gateway. Денежные расчёты и распределение исполняет код. N-1/N-2 показывают сценарии и ограничения. Недоступная обязательная модель даёт ограниченную ошибку и допустимый ручной путь, универсального fallback нет. Технический журнал не гарантирует абсолютную неизменяемость от администратора.</a:t>
+            </a:r>
+          </a:p>
         </p:txBody>
       </p:sp>
       <p:sp>
@@ -843,7 +867,11 @@
         <p:txBody>
           <a:bodyPr xmlns:a="http://schemas.openxmlformats.org/drawingml/2006/main"/>
           <a:lstStyle xmlns:a="http://schemas.openxmlformats.org/drawingml/2006/main"/>
-          <a:p xmlns:a="http://schemas.openxmlformats.org/drawingml/2006/main"/>
+          <a:p xmlns:a="http://schemas.openxmlformats.org/drawingml/2006/main">
+            <a:r>
+              <a:t>Источник: docs/analysis/stage-16.md, контракт business-analysis-1 и решения S16.04. 0 ₽ — текущий сбор продукта. −97 ₽ — модельный операционный результат платформы при нулевом сборе в заданном синтетическом сценарии. 150 ₽ — сценарный доход, не тариф: результат 53 ₽ операционно и −197 ₽ после заданных долей разработки/привлечения. GMV не является доходом. Реальные банковские платежи не подключены, учёт оплаты не является банковским подтверждением. Реестровая проверка и юридическая электронная подпись не заявляются.</a:t>
+            </a:r>
+          </a:p>
         </p:txBody>
       </p:sp>
       <p:sp>
@@ -909,7 +937,11 @@
         <p:txBody>
           <a:bodyPr xmlns:a="http://schemas.openxmlformats.org/drawingml/2006/main"/>
           <a:lstStyle xmlns:a="http://schemas.openxmlformats.org/drawingml/2006/main"/>
-          <a:p xmlns:a="http://schemas.openxmlformats.org/drawingml/2006/main"/>
+          <a:p xmlns:a="http://schemas.openxmlformats.org/drawingml/2006/main">
+            <a:r>
+              <a:t>Источники: NEXT_STEPS.md S15.03/S17/S18; docs/operations/stage-15.md, локальная сеть и оборудование. Физическая запись микрофона, доверенный HTTPS и путь обеих ролей на втором устройстве остаются непроверенными. Функциональное видео и финальная репетиция открыты. Критерии Приложения 1: K1 глубина понимания 10, K2 среда агентов 20, K3 архитектура/реализуемость 15, K4 автоматизация поставщика 25, K5 качество прототипа/показа 30. Оценка жюри не предсказывается. Материалы и ответственные люди требуют отдельного подтверждения. Обязательная передача репозитория не заявляется.</a:t>
+            </a:r>
+          </a:p>
         </p:txBody>
       </p:sp>
       <p:sp>
@@ -975,7 +1007,7 @@
   </p:cSld>
   <p:clrMap bg1="lt1" tx1="dk1" bg2="lt2" tx2="dk2" accent1="accent1" accent2="accent2" accent3="accent3" accent4="accent4" accent5="accent5" accent6="accent6" hlink="hlink" folHlink="folHlink"/>
   <p:sldLayoutIdLst>
-    <p:sldLayoutId xmlns:r="http://schemas.openxmlformats.org/officeDocument/2006/relationships" id="2147483649" r:id="R129cf93daa034056"/>
+    <p:sldLayoutId xmlns:r="http://schemas.openxmlformats.org/officeDocument/2006/relationships" id="2147483649" r:id="Rd1e8925a8baf4c21"/>
   </p:sldLayoutIdLst>
   <p:txStyles>
     <p:titleStyle>
@@ -1547,6 +1579,7 @@
           <a:lstStyle xmlns:a="http://schemas.openxmlformats.org/drawingml/2006/main"/>
           <a:p xmlns:a="http://schemas.openxmlformats.org/drawingml/2006/main">
             <a:pPr>
+              <a:buNone/>
               <a:defRPr sz="1800" b="1">
                 <a:solidFill>
                   <a:srgbClr val="3D8DFF"/>
@@ -1603,6 +1636,7 @@
           <a:lstStyle xmlns:a="http://schemas.openxmlformats.org/drawingml/2006/main"/>
           <a:p xmlns:a="http://schemas.openxmlformats.org/drawingml/2006/main">
             <a:pPr>
+              <a:buNone/>
               <a:defRPr sz="6150" b="1">
                 <a:solidFill>
                   <a:srgbClr val="000000"/>
@@ -1659,6 +1693,7 @@
           <a:lstStyle xmlns:a="http://schemas.openxmlformats.org/drawingml/2006/main"/>
           <a:p xmlns:a="http://schemas.openxmlformats.org/drawingml/2006/main">
             <a:pPr>
+              <a:buNone/>
               <a:defRPr sz="2250" b="0">
                 <a:solidFill>
                   <a:srgbClr val="000000"/>
@@ -1677,7 +1712,7 @@
                 <a:ea typeface="Helvetica Neue"/>
                 <a:cs typeface="Helvetica Neue"/>
               </a:rPr>
-              <a:t>Спрос объединяется. Производство получает заказ. Решение подтверждает человек.</a:t>
+              <a:t>Система предлагает совместимую партию. Обязательства подтверждают участники.</a:t>
             </a:r>
           </a:p>
         </p:txBody>
@@ -1737,6 +1772,7 @@
           <a:lstStyle xmlns:a="http://schemas.openxmlformats.org/drawingml/2006/main"/>
           <a:p xmlns:a="http://schemas.openxmlformats.org/drawingml/2006/main">
             <a:pPr>
+              <a:buNone/>
               <a:defRPr sz="3000" b="1">
                 <a:solidFill>
                   <a:srgbClr val="000000"/>
@@ -1755,7 +1791,7 @@
                 <a:ea typeface="Helvetica Neue"/>
                 <a:cs typeface="Helvetica Neue"/>
               </a:rPr>
-              <a:t>Проблема видна на одном заказе</a:t>
+              <a:t>Потребности разных российских бизнесов</a:t>
             </a:r>
           </a:p>
         </p:txBody>
@@ -1793,6 +1829,7 @@
           <a:lstStyle xmlns:a="http://schemas.openxmlformats.org/drawingml/2006/main"/>
           <a:p xmlns:a="http://schemas.openxmlformats.org/drawingml/2006/main">
             <a:pPr>
+              <a:buNone/>
               <a:defRPr sz="1050" b="0">
                 <a:solidFill>
                   <a:srgbClr val="000000"/>
@@ -1849,6 +1886,7 @@
           <a:lstStyle xmlns:a="http://schemas.openxmlformats.org/drawingml/2006/main"/>
           <a:p xmlns:a="http://schemas.openxmlformats.org/drawingml/2006/main">
             <a:pPr>
+              <a:buNone/>
               <a:defRPr sz="1650" b="0">
                 <a:solidFill>
                   <a:srgbClr val="000000"/>
@@ -1867,7 +1905,7 @@
                 <a:ea typeface="Helvetica Neue"/>
                 <a:cs typeface="Helvetica Neue"/>
               </a:rPr>
-              <a:t>Демосценарий: кофейне нужны 5 000 стаканов, а производитель запускает линию только от 50 000. Обычный каталог не превращает этот разрыв в сделку.</a:t>
+              <a:t>S16 разбирает ручные операции разных бизнесов. Совместимость, допуск и полная стоимость важнее одной цены. Постоянный поставщик и прямое КП сохраняются как альтернативы.</a:t>
             </a:r>
           </a:p>
         </p:txBody>
@@ -1936,6 +1974,7 @@
           <a:lstStyle xmlns:a="http://schemas.openxmlformats.org/drawingml/2006/main"/>
           <a:p xmlns:a="http://schemas.openxmlformats.org/drawingml/2006/main">
             <a:pPr>
+              <a:buNone/>
               <a:defRPr sz="4050" b="1">
                 <a:solidFill>
                   <a:srgbClr val="000000"/>
@@ -1954,7 +1993,7 @@
                 <a:ea typeface="Helvetica Neue"/>
                 <a:cs typeface="Helvetica Neue"/>
               </a:rPr>
-              <a:t>5 000</a:t>
+              <a:t>13</a:t>
             </a:r>
           </a:p>
         </p:txBody>
@@ -1992,6 +2031,7 @@
           <a:lstStyle xmlns:a="http://schemas.openxmlformats.org/drawingml/2006/main"/>
           <a:p xmlns:a="http://schemas.openxmlformats.org/drawingml/2006/main">
             <a:pPr>
+              <a:buNone/>
               <a:defRPr sz="1725" b="0">
                 <a:solidFill>
                   <a:srgbClr val="000000"/>
@@ -2010,7 +2050,7 @@
                 <a:ea typeface="Helvetica Neue"/>
                 <a:cs typeface="Helvetica Neue"/>
               </a:rPr>
-              <a:t>потребность кофейни, шт.</a:t>
+              <a:t>проблем B01–B13</a:t>
             </a:r>
           </a:p>
         </p:txBody>
@@ -2079,6 +2119,7 @@
           <a:lstStyle xmlns:a="http://schemas.openxmlformats.org/drawingml/2006/main"/>
           <a:p xmlns:a="http://schemas.openxmlformats.org/drawingml/2006/main">
             <a:pPr>
+              <a:buNone/>
               <a:defRPr sz="4050" b="1">
                 <a:solidFill>
                   <a:srgbClr val="000000"/>
@@ -2097,7 +2138,7 @@
                 <a:ea typeface="Helvetica Neue"/>
                 <a:cs typeface="Helvetica Neue"/>
               </a:rPr>
-              <a:t>50 000</a:t>
+              <a:t>12</a:t>
             </a:r>
           </a:p>
         </p:txBody>
@@ -2135,6 +2176,7 @@
           <a:lstStyle xmlns:a="http://schemas.openxmlformats.org/drawingml/2006/main"/>
           <a:p xmlns:a="http://schemas.openxmlformats.org/drawingml/2006/main">
             <a:pPr>
+              <a:buNone/>
               <a:defRPr sz="1725" b="0">
                 <a:solidFill>
                   <a:srgbClr val="000000"/>
@@ -2153,7 +2195,7 @@
                 <a:ea typeface="Helvetica Neue"/>
                 <a:cs typeface="Helvetica Neue"/>
               </a:rPr>
-              <a:t>минимальная партия, шт.</a:t>
+              <a:t>разделов каталога</a:t>
             </a:r>
           </a:p>
         </p:txBody>
@@ -2222,6 +2264,7 @@
           <a:lstStyle xmlns:a="http://schemas.openxmlformats.org/drawingml/2006/main"/>
           <a:p xmlns:a="http://schemas.openxmlformats.org/drawingml/2006/main">
             <a:pPr>
+              <a:buNone/>
               <a:defRPr sz="4050" b="1">
                 <a:solidFill>
                   <a:srgbClr val="000000"/>
@@ -2240,7 +2283,7 @@
                 <a:ea typeface="Helvetica Neue"/>
                 <a:cs typeface="Helvetica Neue"/>
               </a:rPr>
-              <a:t>0</a:t>
+              <a:t>47</a:t>
             </a:r>
           </a:p>
         </p:txBody>
@@ -2278,6 +2321,7 @@
           <a:lstStyle xmlns:a="http://schemas.openxmlformats.org/drawingml/2006/main"/>
           <a:p xmlns:a="http://schemas.openxmlformats.org/drawingml/2006/main">
             <a:pPr>
+              <a:buNone/>
               <a:defRPr sz="1725" b="0">
                 <a:solidFill>
                   <a:srgbClr val="000000"/>
@@ -2296,7 +2340,7 @@
                 <a:ea typeface="Helvetica Neue"/>
                 <a:cs typeface="Helvetica Neue"/>
               </a:rPr>
-              <a:t>сделок без объединения</a:t>
+              <a:t>предметных листьев</a:t>
             </a:r>
           </a:p>
         </p:txBody>
@@ -2356,6 +2400,7 @@
           <a:lstStyle xmlns:a="http://schemas.openxmlformats.org/drawingml/2006/main"/>
           <a:p xmlns:a="http://schemas.openxmlformats.org/drawingml/2006/main">
             <a:pPr>
+              <a:buNone/>
               <a:defRPr sz="3000" b="1">
                 <a:solidFill>
                   <a:srgbClr val="000000"/>
@@ -2374,7 +2419,7 @@
                 <a:ea typeface="Helvetica Neue"/>
                 <a:cs typeface="Helvetica Neue"/>
               </a:rPr>
-              <a:t>ПоРукам превращает разрозненный спрос в исполнимую партию</a:t>
+              <a:t>Совместимость, расчёт и согласие сторон</a:t>
             </a:r>
           </a:p>
         </p:txBody>
@@ -2412,6 +2457,7 @@
           <a:lstStyle xmlns:a="http://schemas.openxmlformats.org/drawingml/2006/main"/>
           <a:p xmlns:a="http://schemas.openxmlformats.org/drawingml/2006/main">
             <a:pPr>
+              <a:buNone/>
               <a:defRPr sz="1050" b="0">
                 <a:solidFill>
                   <a:srgbClr val="000000"/>
@@ -2530,6 +2576,7 @@
           <a:lstStyle xmlns:a="http://schemas.openxmlformats.org/drawingml/2006/main"/>
           <a:p xmlns:a="http://schemas.openxmlformats.org/drawingml/2006/main">
             <a:pPr>
+              <a:buNone/>
               <a:defRPr sz="1350" b="1">
                 <a:solidFill>
                   <a:srgbClr val="3D8DFF"/>
@@ -2586,6 +2633,7 @@
           <a:lstStyle xmlns:a="http://schemas.openxmlformats.org/drawingml/2006/main"/>
           <a:p xmlns:a="http://schemas.openxmlformats.org/drawingml/2006/main">
             <a:pPr>
+              <a:buNone/>
               <a:defRPr sz="1950" b="1">
                 <a:solidFill>
                   <a:srgbClr val="000000"/>
@@ -2642,6 +2690,7 @@
           <a:lstStyle xmlns:a="http://schemas.openxmlformats.org/drawingml/2006/main"/>
           <a:p xmlns:a="http://schemas.openxmlformats.org/drawingml/2006/main">
             <a:pPr>
+              <a:buNone/>
               <a:defRPr sz="1575" b="0">
                 <a:solidFill>
                   <a:srgbClr val="000000"/>
@@ -2660,7 +2709,7 @@
                 <a:ea typeface="Helvetica Neue"/>
                 <a:cs typeface="Helvetica Neue"/>
               </a:rPr>
-              <a:t>Агент фиксирует объём, свойства, срок и логистику.</a:t>
+              <a:t>Агент готовит черновик с источниками. Человек проверяет неизвестные поля и конфликты.</a:t>
             </a:r>
           </a:p>
         </p:txBody>
@@ -2729,6 +2778,7 @@
           <a:lstStyle xmlns:a="http://schemas.openxmlformats.org/drawingml/2006/main"/>
           <a:p xmlns:a="http://schemas.openxmlformats.org/drawingml/2006/main">
             <a:pPr>
+              <a:buNone/>
               <a:defRPr sz="1350" b="1">
                 <a:solidFill>
                   <a:srgbClr val="3D8DFF"/>
@@ -2785,6 +2835,7 @@
           <a:lstStyle xmlns:a="http://schemas.openxmlformats.org/drawingml/2006/main"/>
           <a:p xmlns:a="http://schemas.openxmlformats.org/drawingml/2006/main">
             <a:pPr>
+              <a:buNone/>
               <a:defRPr sz="1950" b="1">
                 <a:solidFill>
                   <a:srgbClr val="000000"/>
@@ -2803,7 +2854,7 @@
                 <a:ea typeface="Helvetica Neue"/>
                 <a:cs typeface="Helvetica Neue"/>
               </a:rPr>
-              <a:t>Объяснимая коалиция</a:t>
+              <a:t>Сопоставимый расчёт</a:t>
             </a:r>
           </a:p>
         </p:txBody>
@@ -2841,6 +2892,7 @@
           <a:lstStyle xmlns:a="http://schemas.openxmlformats.org/drawingml/2006/main"/>
           <a:p xmlns:a="http://schemas.openxmlformats.org/drawingml/2006/main">
             <a:pPr>
+              <a:buNone/>
               <a:defRPr sz="1575" b="0">
                 <a:solidFill>
                   <a:srgbClr val="000000"/>
@@ -2859,7 +2911,7 @@
                 <a:ea typeface="Helvetica Neue"/>
                 <a:cs typeface="Helvetica Neue"/>
               </a:rPr>
-              <a:t>Код и OR-Tools считают совместимость, стоимость и выгоду.</a:t>
+              <a:t>Код считает рубли и объёмы. Выгода неизвестна без сопоставимой базы.</a:t>
             </a:r>
           </a:p>
         </p:txBody>
@@ -2928,6 +2980,7 @@
           <a:lstStyle xmlns:a="http://schemas.openxmlformats.org/drawingml/2006/main"/>
           <a:p xmlns:a="http://schemas.openxmlformats.org/drawingml/2006/main">
             <a:pPr>
+              <a:buNone/>
               <a:defRPr sz="1350" b="1">
                 <a:solidFill>
                   <a:srgbClr val="3D8DFF"/>
@@ -2984,6 +3037,7 @@
           <a:lstStyle xmlns:a="http://schemas.openxmlformats.org/drawingml/2006/main"/>
           <a:p xmlns:a="http://schemas.openxmlformats.org/drawingml/2006/main">
             <a:pPr>
+              <a:buNone/>
               <a:defRPr sz="1950" b="1">
                 <a:solidFill>
                   <a:srgbClr val="000000"/>
@@ -3040,6 +3094,7 @@
           <a:lstStyle xmlns:a="http://schemas.openxmlformats.org/drawingml/2006/main"/>
           <a:p xmlns:a="http://schemas.openxmlformats.org/drawingml/2006/main">
             <a:pPr>
+              <a:buNone/>
               <a:defRPr sz="1575" b="0">
                 <a:solidFill>
                   <a:srgbClr val="000000"/>
@@ -3058,7 +3113,7 @@
                 <a:ea typeface="Helvetica Neue"/>
                 <a:cs typeface="Helvetica Neue"/>
               </a:rPr>
-              <a:t>Цена, резерв и сделка меняются только после решения человека.</a:t>
+              <a:t>Обязательство требует актуального согласия сторон. Недобор группы сохраняет прямое КП.</a:t>
             </a:r>
           </a:p>
         </p:txBody>
@@ -3118,6 +3173,7 @@
           <a:lstStyle xmlns:a="http://schemas.openxmlformats.org/drawingml/2006/main"/>
           <a:p xmlns:a="http://schemas.openxmlformats.org/drawingml/2006/main">
             <a:pPr>
+              <a:buNone/>
               <a:defRPr sz="3000" b="1">
                 <a:solidFill>
                   <a:srgbClr val="000000"/>
@@ -3136,7 +3192,7 @@
                 <a:ea typeface="Helvetica Neue"/>
                 <a:cs typeface="Helvetica Neue"/>
               </a:rPr>
-              <a:t>Одна система убирает ручную работу с обеих сторон</a:t>
+              <a:t>Работа покупателя и поставщика</a:t>
             </a:r>
           </a:p>
         </p:txBody>
@@ -3174,6 +3230,7 @@
           <a:lstStyle xmlns:a="http://schemas.openxmlformats.org/drawingml/2006/main"/>
           <a:p xmlns:a="http://schemas.openxmlformats.org/drawingml/2006/main">
             <a:pPr>
+              <a:buNone/>
               <a:defRPr sz="1050" b="0">
                 <a:solidFill>
                   <a:srgbClr val="000000"/>
@@ -3261,6 +3318,7 @@
           <a:lstStyle xmlns:a="http://schemas.openxmlformats.org/drawingml/2006/main"/>
           <a:p xmlns:a="http://schemas.openxmlformats.org/drawingml/2006/main">
             <a:pPr>
+              <a:buNone/>
               <a:defRPr sz="1875" b="1">
                 <a:solidFill>
                   <a:srgbClr val="3D8DFF"/>
@@ -3317,6 +3375,7 @@
           <a:lstStyle xmlns:a="http://schemas.openxmlformats.org/drawingml/2006/main"/>
           <a:p xmlns:a="http://schemas.openxmlformats.org/drawingml/2006/main">
             <a:pPr>
+              <a:buNone/>
               <a:defRPr sz="1800" b="0">
                 <a:solidFill>
                   <a:srgbClr val="000000"/>
@@ -3335,7 +3394,7 @@
                 <a:ea typeface="Helvetica Neue"/>
                 <a:cs typeface="Helvetica Neue"/>
               </a:rPr>
-              <a:t>Формирует запрос из диалога, получает сравнимые предложения и доступ к малому опту.</a:t>
+              <a:t>Готовит запрос и сравнивает предложения. Неизвестные затраты и несопоставимые условия видны отдельно.</a:t>
             </a:r>
           </a:p>
         </p:txBody>
@@ -3404,6 +3463,7 @@
           <a:lstStyle xmlns:a="http://schemas.openxmlformats.org/drawingml/2006/main"/>
           <a:p xmlns:a="http://schemas.openxmlformats.org/drawingml/2006/main">
             <a:pPr>
+              <a:buNone/>
               <a:defRPr sz="1875" b="1">
                 <a:solidFill>
                   <a:srgbClr val="3D8DFF"/>
@@ -3460,6 +3520,7 @@
           <a:lstStyle xmlns:a="http://schemas.openxmlformats.org/drawingml/2006/main"/>
           <a:p xmlns:a="http://schemas.openxmlformats.org/drawingml/2006/main">
             <a:pPr>
+              <a:buNone/>
               <a:defRPr sz="1800" b="0">
                 <a:solidFill>
                   <a:srgbClr val="000000"/>
@@ -3478,7 +3539,7 @@
                 <a:ea typeface="Helvetica Neue"/>
                 <a:cs typeface="Helvetica Neue"/>
               </a:rPr>
-              <a:t>Видит подтверждённый спрос, предлагает условия и загружает свободную мощность.</a:t>
+              <a:t>Готовит КП, ведёт каталог и подтверждает исполнение. Правки и согласования входят в оценку труда.</a:t>
             </a:r>
           </a:p>
         </p:txBody>
@@ -3547,6 +3608,7 @@
           <a:lstStyle xmlns:a="http://schemas.openxmlformats.org/drawingml/2006/main"/>
           <a:p xmlns:a="http://schemas.openxmlformats.org/drawingml/2006/main">
             <a:pPr>
+              <a:buNone/>
               <a:defRPr sz="1875" b="1">
                 <a:solidFill>
                   <a:srgbClr val="3D8DFF"/>
@@ -3603,6 +3665,7 @@
           <a:lstStyle xmlns:a="http://schemas.openxmlformats.org/drawingml/2006/main"/>
           <a:p xmlns:a="http://schemas.openxmlformats.org/drawingml/2006/main">
             <a:pPr>
+              <a:buNone/>
               <a:defRPr sz="1800" b="0">
                 <a:solidFill>
                   <a:srgbClr val="000000"/>
@@ -3621,7 +3684,7 @@
                 <a:ea typeface="Helvetica Neue"/>
                 <a:cs typeface="Helvetica Neue"/>
               </a:rPr>
-              <a:t>Объединяет совместимые объёмы, показывает основания и готовит безопасный сценарий.</a:t>
+              <a:t>Показывает совместимость, полную смету и основания. Резерв сохраняет стоимость и непокрытый объём.</a:t>
             </a:r>
           </a:p>
         </p:txBody>
@@ -3681,6 +3744,7 @@
           <a:lstStyle xmlns:a="http://schemas.openxmlformats.org/drawingml/2006/main"/>
           <a:p xmlns:a="http://schemas.openxmlformats.org/drawingml/2006/main">
             <a:pPr>
+              <a:buNone/>
               <a:defRPr sz="3000" b="1">
                 <a:solidFill>
                   <a:srgbClr val="000000"/>
@@ -3699,7 +3763,7 @@
                 <a:ea typeface="Helvetica Neue"/>
                 <a:cs typeface="Helvetica Neue"/>
               </a:rPr>
-              <a:t>Полноценная карточка товара уже в прототипе</a:t>
+              <a:t>Каталог и границы предметной приёмки</a:t>
             </a:r>
           </a:p>
         </p:txBody>
@@ -3737,6 +3801,7 @@
           <a:lstStyle xmlns:a="http://schemas.openxmlformats.org/drawingml/2006/main"/>
           <a:p xmlns:a="http://schemas.openxmlformats.org/drawingml/2006/main">
             <a:pPr>
+              <a:buNone/>
               <a:defRPr sz="1050" b="0">
                 <a:solidFill>
                   <a:srgbClr val="000000"/>
@@ -3793,6 +3858,7 @@
           <a:lstStyle xmlns:a="http://schemas.openxmlformats.org/drawingml/2006/main"/>
           <a:p xmlns:a="http://schemas.openxmlformats.org/drawingml/2006/main">
             <a:pPr>
+              <a:buNone/>
               <a:defRPr sz="1650" b="0">
                 <a:solidFill>
                   <a:srgbClr val="000000"/>
@@ -3811,7 +3877,7 @@
                 <a:ea typeface="Helvetica Neue"/>
                 <a:cs typeface="Helvetica Neue"/>
               </a:rPr>
-              <a:t>Название задаёт продавец; категория и подкатегория помогают поиску. Публикация доступна только верифицированной компании.</a:t>
+              <a:t>В S15 девять листьев прошли API/DB-путь до приёмки и повтора. Профиль остальных листьев не означает готовый коммерческий путь. Все компании и документы синтетические.</a:t>
             </a:r>
           </a:p>
         </p:txBody>
@@ -3880,6 +3946,7 @@
           <a:lstStyle xmlns:a="http://schemas.openxmlformats.org/drawingml/2006/main"/>
           <a:p xmlns:a="http://schemas.openxmlformats.org/drawingml/2006/main">
             <a:pPr>
+              <a:buNone/>
               <a:defRPr sz="4050" b="1">
                 <a:solidFill>
                   <a:srgbClr val="000000"/>
@@ -3898,7 +3965,7 @@
                 <a:ea typeface="Helvetica Neue"/>
                 <a:cs typeface="Helvetica Neue"/>
               </a:rPr>
-              <a:t>25</a:t>
+              <a:t>9</a:t>
             </a:r>
           </a:p>
         </p:txBody>
@@ -3936,6 +4003,7 @@
           <a:lstStyle xmlns:a="http://schemas.openxmlformats.org/drawingml/2006/main"/>
           <a:p xmlns:a="http://schemas.openxmlformats.org/drawingml/2006/main">
             <a:pPr>
+              <a:buNone/>
               <a:defRPr sz="1725" b="0">
                 <a:solidFill>
                   <a:srgbClr val="000000"/>
@@ -3954,7 +4022,31 @@
                 <a:ea typeface="Helvetica Neue"/>
                 <a:cs typeface="Helvetica Neue"/>
               </a:rPr>
-              <a:t>характеристик максимум</a:t>
+              <a:t>листов с приёмкой</a:t>
+            </a:r>
+          </a:p>
+          <a:p xmlns:a="http://schemas.openxmlformats.org/drawingml/2006/main">
+            <a:pPr>
+              <a:buNone/>
+              <a:defRPr sz="1725" b="0">
+                <a:solidFill>
+                  <a:srgbClr val="000000"/>
+                </a:solidFill>
+                <a:latin typeface="Helvetica Neue"/>
+                <a:ea typeface="Helvetica Neue"/>
+                <a:cs typeface="Helvetica Neue"/>
+              </a:defRPr>
+            </a:pPr>
+            <a:r>
+              <a:rPr sz="1725" b="0">
+                <a:solidFill>
+                  <a:srgbClr val="000000"/>
+                </a:solidFill>
+                <a:latin typeface="Helvetica Neue"/>
+                <a:ea typeface="Helvetica Neue"/>
+                <a:cs typeface="Helvetica Neue"/>
+              </a:rPr>
+              <a:t>в сценариях S15</a:t>
             </a:r>
           </a:p>
         </p:txBody>
@@ -4023,6 +4115,7 @@
           <a:lstStyle xmlns:a="http://schemas.openxmlformats.org/drawingml/2006/main"/>
           <a:p xmlns:a="http://schemas.openxmlformats.org/drawingml/2006/main">
             <a:pPr>
+              <a:buNone/>
               <a:defRPr sz="4050" b="1">
                 <a:solidFill>
                   <a:srgbClr val="000000"/>
@@ -4041,7 +4134,7 @@
                 <a:ea typeface="Helvetica Neue"/>
                 <a:cs typeface="Helvetica Neue"/>
               </a:rPr>
-              <a:t>5</a:t>
+              <a:t>46</a:t>
             </a:r>
           </a:p>
         </p:txBody>
@@ -4079,6 +4172,7 @@
           <a:lstStyle xmlns:a="http://schemas.openxmlformats.org/drawingml/2006/main"/>
           <a:p xmlns:a="http://schemas.openxmlformats.org/drawingml/2006/main">
             <a:pPr>
+              <a:buNone/>
               <a:defRPr sz="1725" b="0">
                 <a:solidFill>
                   <a:srgbClr val="000000"/>
@@ -4097,7 +4191,31 @@
                 <a:ea typeface="Helvetica Neue"/>
                 <a:cs typeface="Helvetica Neue"/>
               </a:rPr>
-              <a:t>фотографий максимум</a:t>
+              <a:t>поддерживаемых</a:t>
+            </a:r>
+          </a:p>
+          <a:p xmlns:a="http://schemas.openxmlformats.org/drawingml/2006/main">
+            <a:pPr>
+              <a:buNone/>
+              <a:defRPr sz="1725" b="0">
+                <a:solidFill>
+                  <a:srgbClr val="000000"/>
+                </a:solidFill>
+                <a:latin typeface="Helvetica Neue"/>
+                <a:ea typeface="Helvetica Neue"/>
+                <a:cs typeface="Helvetica Neue"/>
+              </a:defRPr>
+            </a:pPr>
+            <a:r>
+              <a:rPr sz="1725" b="0">
+                <a:solidFill>
+                  <a:srgbClr val="000000"/>
+                </a:solidFill>
+                <a:latin typeface="Helvetica Neue"/>
+                <a:ea typeface="Helvetica Neue"/>
+                <a:cs typeface="Helvetica Neue"/>
+              </a:rPr>
+              <a:t>предметных профилей</a:t>
             </a:r>
           </a:p>
         </p:txBody>
@@ -4166,6 +4284,7 @@
           <a:lstStyle xmlns:a="http://schemas.openxmlformats.org/drawingml/2006/main"/>
           <a:p xmlns:a="http://schemas.openxmlformats.org/drawingml/2006/main">
             <a:pPr>
+              <a:buNone/>
               <a:defRPr sz="4050" b="1">
                 <a:solidFill>
                   <a:srgbClr val="000000"/>
@@ -4184,7 +4303,7 @@
                 <a:ea typeface="Helvetica Neue"/>
                 <a:cs typeface="Helvetica Neue"/>
               </a:rPr>
-              <a:t>10</a:t>
+              <a:t>1</a:t>
             </a:r>
           </a:p>
         </p:txBody>
@@ -4222,6 +4341,7 @@
           <a:lstStyle xmlns:a="http://schemas.openxmlformats.org/drawingml/2006/main"/>
           <a:p xmlns:a="http://schemas.openxmlformats.org/drawingml/2006/main">
             <a:pPr>
+              <a:buNone/>
               <a:defRPr sz="1725" b="0">
                 <a:solidFill>
                   <a:srgbClr val="000000"/>
@@ -4240,7 +4360,31 @@
                 <a:ea typeface="Helvetica Neue"/>
                 <a:cs typeface="Helvetica Neue"/>
               </a:rPr>
-              <a:t>ценовых ступеней</a:t>
+              <a:t>неподдерживаемый</a:t>
+            </a:r>
+          </a:p>
+          <a:p xmlns:a="http://schemas.openxmlformats.org/drawingml/2006/main">
+            <a:pPr>
+              <a:buNone/>
+              <a:defRPr sz="1725" b="0">
+                <a:solidFill>
+                  <a:srgbClr val="000000"/>
+                </a:solidFill>
+                <a:latin typeface="Helvetica Neue"/>
+                <a:ea typeface="Helvetica Neue"/>
+                <a:cs typeface="Helvetica Neue"/>
+              </a:defRPr>
+            </a:pPr>
+            <a:r>
+              <a:rPr sz="1725" b="0">
+                <a:solidFill>
+                  <a:srgbClr val="000000"/>
+                </a:solidFill>
+                <a:latin typeface="Helvetica Neue"/>
+                <a:ea typeface="Helvetica Neue"/>
+                <a:cs typeface="Helvetica Neue"/>
+              </a:rPr>
+              <a:t>медицинский лист</a:t>
             </a:r>
           </a:p>
         </p:txBody>
@@ -4300,6 +4444,7 @@
           <a:lstStyle xmlns:a="http://schemas.openxmlformats.org/drawingml/2006/main"/>
           <a:p xmlns:a="http://schemas.openxmlformats.org/drawingml/2006/main">
             <a:pPr>
+              <a:buNone/>
               <a:defRPr sz="3000" b="1">
                 <a:solidFill>
                   <a:srgbClr val="000000"/>
@@ -4356,6 +4501,7 @@
           <a:lstStyle xmlns:a="http://schemas.openxmlformats.org/drawingml/2006/main"/>
           <a:p xmlns:a="http://schemas.openxmlformats.org/drawingml/2006/main">
             <a:pPr>
+              <a:buNone/>
               <a:defRPr sz="1050" b="0">
                 <a:solidFill>
                   <a:srgbClr val="000000"/>
@@ -4443,6 +4589,7 @@
           <a:lstStyle xmlns:a="http://schemas.openxmlformats.org/drawingml/2006/main"/>
           <a:p xmlns:a="http://schemas.openxmlformats.org/drawingml/2006/main">
             <a:pPr>
+              <a:buNone/>
               <a:defRPr sz="1875" b="1">
                 <a:solidFill>
                   <a:srgbClr val="3D8DFF"/>
@@ -4499,6 +4646,7 @@
           <a:lstStyle xmlns:a="http://schemas.openxmlformats.org/drawingml/2006/main"/>
           <a:p xmlns:a="http://schemas.openxmlformats.org/drawingml/2006/main">
             <a:pPr>
+              <a:buNone/>
               <a:defRPr sz="1800" b="0">
                 <a:solidFill>
                   <a:srgbClr val="000000"/>
@@ -4517,7 +4665,7 @@
                 <a:ea typeface="Helvetica Neue"/>
                 <a:cs typeface="Helvetica Neue"/>
               </a:rPr>
-              <a:t>Модель уточняет и объясняет. Клиентские файлы не уходят во внешнюю нейросеть.</a:t>
+              <a:t>Модель работает через Gateway. Исходные файлы остаются в локальном контуре.</a:t>
             </a:r>
           </a:p>
         </p:txBody>
@@ -4586,6 +4734,7 @@
           <a:lstStyle xmlns:a="http://schemas.openxmlformats.org/drawingml/2006/main"/>
           <a:p xmlns:a="http://schemas.openxmlformats.org/drawingml/2006/main">
             <a:pPr>
+              <a:buNone/>
               <a:defRPr sz="1875" b="1">
                 <a:solidFill>
                   <a:srgbClr val="3D8DFF"/>
@@ -4642,6 +4791,7 @@
           <a:lstStyle xmlns:a="http://schemas.openxmlformats.org/drawingml/2006/main"/>
           <a:p xmlns:a="http://schemas.openxmlformats.org/drawingml/2006/main">
             <a:pPr>
+              <a:buNone/>
               <a:defRPr sz="1800" b="0">
                 <a:solidFill>
                   <a:srgbClr val="000000"/>
@@ -4660,7 +4810,7 @@
                 <a:ea typeface="Helvetica Neue"/>
                 <a:cs typeface="Helvetica Neue"/>
               </a:rPr>
-              <a:t>Детерминированно считает рубли, объёмы, логистику и N-1/N-2.</a:t>
+              <a:t>Код считает рубли и объёмы. N-1/N-2 показывают покрытие и ограничения резерва.</a:t>
             </a:r>
           </a:p>
         </p:txBody>
@@ -4729,6 +4879,7 @@
           <a:lstStyle xmlns:a="http://schemas.openxmlformats.org/drawingml/2006/main"/>
           <a:p xmlns:a="http://schemas.openxmlformats.org/drawingml/2006/main">
             <a:pPr>
+              <a:buNone/>
               <a:defRPr sz="1875" b="1">
                 <a:solidFill>
                   <a:srgbClr val="3D8DFF"/>
@@ -4785,6 +4936,7 @@
           <a:lstStyle xmlns:a="http://schemas.openxmlformats.org/drawingml/2006/main"/>
           <a:p xmlns:a="http://schemas.openxmlformats.org/drawingml/2006/main">
             <a:pPr>
+              <a:buNone/>
               <a:defRPr sz="1800" b="0">
                 <a:solidFill>
                   <a:srgbClr val="000000"/>
@@ -4803,7 +4955,7 @@
                 <a:ea typeface="Helvetica Neue"/>
                 <a:cs typeface="Helvetica Neue"/>
               </a:rPr>
-              <a:t>Блокирует критичное действие, пока участник явно не подтвердил условия.</a:t>
+              <a:t>Критичные действия требуют актуального согласия уполномоченного участника.</a:t>
             </a:r>
           </a:p>
         </p:txBody>
@@ -4863,6 +5015,7 @@
           <a:lstStyle xmlns:a="http://schemas.openxmlformats.org/drawingml/2006/main"/>
           <a:p xmlns:a="http://schemas.openxmlformats.org/drawingml/2006/main">
             <a:pPr>
+              <a:buNone/>
               <a:defRPr sz="3000" b="1">
                 <a:solidFill>
                   <a:srgbClr val="000000"/>
@@ -4881,7 +5034,7 @@
                 <a:ea typeface="Helvetica Neue"/>
                 <a:cs typeface="Helvetica Neue"/>
               </a:rPr>
-              <a:t>Монетизация не закрывает базовый маркетплейс</a:t>
+              <a:t>Экономика с явными допущениями</a:t>
             </a:r>
           </a:p>
         </p:txBody>
@@ -4919,6 +5072,7 @@
           <a:lstStyle xmlns:a="http://schemas.openxmlformats.org/drawingml/2006/main"/>
           <a:p xmlns:a="http://schemas.openxmlformats.org/drawingml/2006/main">
             <a:pPr>
+              <a:buNone/>
               <a:defRPr sz="1050" b="0">
                 <a:solidFill>
                   <a:srgbClr val="000000"/>
@@ -4975,6 +5129,7 @@
           <a:lstStyle xmlns:a="http://schemas.openxmlformats.org/drawingml/2006/main"/>
           <a:p xmlns:a="http://schemas.openxmlformats.org/drawingml/2006/main">
             <a:pPr>
+              <a:buNone/>
               <a:defRPr sz="1650" b="0">
                 <a:solidFill>
                   <a:srgbClr val="000000"/>
@@ -4993,7 +5148,7 @@
                 <a:ea typeface="Helvetica Neue"/>
                 <a:cs typeface="Helvetica Neue"/>
               </a:rPr>
-              <a:t>Каталог и ручные операции остаются бесплатными. ИИ-закупки можно проверить до подписки; платежи в прототипе не подключены.</a:t>
+              <a:t>Модель S16 сохраняет отрицательные исходы и неизвестные затраты. Подписка и комиссия задаются как сценарные параметры. Реальные платежи не подключены.</a:t>
             </a:r>
           </a:p>
         </p:txBody>
@@ -5062,6 +5217,7 @@
           <a:lstStyle xmlns:a="http://schemas.openxmlformats.org/drawingml/2006/main"/>
           <a:p xmlns:a="http://schemas.openxmlformats.org/drawingml/2006/main">
             <a:pPr>
+              <a:buNone/>
               <a:defRPr sz="4050" b="1">
                 <a:solidFill>
                   <a:srgbClr val="000000"/>
@@ -5118,6 +5274,7 @@
           <a:lstStyle xmlns:a="http://schemas.openxmlformats.org/drawingml/2006/main"/>
           <a:p xmlns:a="http://schemas.openxmlformats.org/drawingml/2006/main">
             <a:pPr>
+              <a:buNone/>
               <a:defRPr sz="1725" b="0">
                 <a:solidFill>
                   <a:srgbClr val="000000"/>
@@ -5136,7 +5293,7 @@
                 <a:ea typeface="Helvetica Neue"/>
                 <a:cs typeface="Helvetica Neue"/>
               </a:rPr>
-              <a:t>базовый доступ</a:t>
+              <a:t>текущий сбор платформы</a:t>
             </a:r>
           </a:p>
         </p:txBody>
@@ -5205,6 +5362,7 @@
           <a:lstStyle xmlns:a="http://schemas.openxmlformats.org/drawingml/2006/main"/>
           <a:p xmlns:a="http://schemas.openxmlformats.org/drawingml/2006/main">
             <a:pPr>
+              <a:buNone/>
               <a:defRPr sz="4050" b="1">
                 <a:solidFill>
                   <a:srgbClr val="000000"/>
@@ -5223,7 +5381,7 @@
                 <a:ea typeface="Helvetica Neue"/>
                 <a:cs typeface="Helvetica Neue"/>
               </a:rPr>
-              <a:t>2</a:t>
+              <a:t>−97 ₽</a:t>
             </a:r>
           </a:p>
         </p:txBody>
@@ -5261,6 +5419,7 @@
           <a:lstStyle xmlns:a="http://schemas.openxmlformats.org/drawingml/2006/main"/>
           <a:p xmlns:a="http://schemas.openxmlformats.org/drawingml/2006/main">
             <a:pPr>
+              <a:buNone/>
               <a:defRPr sz="1725" b="0">
                 <a:solidFill>
                   <a:srgbClr val="000000"/>
@@ -5279,7 +5438,31 @@
                 <a:ea typeface="Helvetica Neue"/>
                 <a:cs typeface="Helvetica Neue"/>
               </a:rPr>
-              <a:t>пробные ИИ-закупки</a:t>
+              <a:t>операционный результат</a:t>
+            </a:r>
+          </a:p>
+          <a:p xmlns:a="http://schemas.openxmlformats.org/drawingml/2006/main">
+            <a:pPr>
+              <a:buNone/>
+              <a:defRPr sz="1725" b="0">
+                <a:solidFill>
+                  <a:srgbClr val="000000"/>
+                </a:solidFill>
+                <a:latin typeface="Helvetica Neue"/>
+                <a:ea typeface="Helvetica Neue"/>
+                <a:cs typeface="Helvetica Neue"/>
+              </a:defRPr>
+            </a:pPr>
+            <a:r>
+              <a:rPr sz="1725" b="0">
+                <a:solidFill>
+                  <a:srgbClr val="000000"/>
+                </a:solidFill>
+                <a:latin typeface="Helvetica Neue"/>
+                <a:ea typeface="Helvetica Neue"/>
+                <a:cs typeface="Helvetica Neue"/>
+              </a:rPr>
+              <a:t>в сценарии S16</a:t>
             </a:r>
           </a:p>
         </p:txBody>
@@ -5348,6 +5531,7 @@
           <a:lstStyle xmlns:a="http://schemas.openxmlformats.org/drawingml/2006/main"/>
           <a:p xmlns:a="http://schemas.openxmlformats.org/drawingml/2006/main">
             <a:pPr>
+              <a:buNone/>
               <a:defRPr sz="4050" b="1">
                 <a:solidFill>
                   <a:srgbClr val="000000"/>
@@ -5366,7 +5550,7 @@
                 <a:ea typeface="Helvetica Neue"/>
                 <a:cs typeface="Helvetica Neue"/>
               </a:rPr>
-              <a:t>1</a:t>
+              <a:t>150 ₽</a:t>
             </a:r>
           </a:p>
         </p:txBody>
@@ -5404,6 +5588,7 @@
           <a:lstStyle xmlns:a="http://schemas.openxmlformats.org/drawingml/2006/main"/>
           <a:p xmlns:a="http://schemas.openxmlformats.org/drawingml/2006/main">
             <a:pPr>
+              <a:buNone/>
               <a:defRPr sz="1725" b="0">
                 <a:solidFill>
                   <a:srgbClr val="000000"/>
@@ -5422,7 +5607,31 @@
                 <a:ea typeface="Helvetica Neue"/>
                 <a:cs typeface="Helvetica Neue"/>
               </a:rPr>
-              <a:t>подписка как вариант</a:t>
+              <a:t>доход как параметр</a:t>
+            </a:r>
+          </a:p>
+          <a:p xmlns:a="http://schemas.openxmlformats.org/drawingml/2006/main">
+            <a:pPr>
+              <a:buNone/>
+              <a:defRPr sz="1725" b="0">
+                <a:solidFill>
+                  <a:srgbClr val="000000"/>
+                </a:solidFill>
+                <a:latin typeface="Helvetica Neue"/>
+                <a:ea typeface="Helvetica Neue"/>
+                <a:cs typeface="Helvetica Neue"/>
+              </a:defRPr>
+            </a:pPr>
+            <a:r>
+              <a:rPr sz="1725" b="0">
+                <a:solidFill>
+                  <a:srgbClr val="000000"/>
+                </a:solidFill>
+                <a:latin typeface="Helvetica Neue"/>
+                <a:ea typeface="Helvetica Neue"/>
+                <a:cs typeface="Helvetica Neue"/>
+              </a:rPr>
+              <a:t>сценария S16</a:t>
             </a:r>
           </a:p>
         </p:txBody>
@@ -5482,6 +5691,7 @@
           <a:lstStyle xmlns:a="http://schemas.openxmlformats.org/drawingml/2006/main"/>
           <a:p xmlns:a="http://schemas.openxmlformats.org/drawingml/2006/main">
             <a:pPr>
+              <a:buNone/>
               <a:defRPr sz="1800" b="1">
                 <a:solidFill>
                   <a:srgbClr val="3D8DFF"/>
@@ -5500,7 +5710,7 @@
                 <a:ea typeface="Helvetica Neue"/>
                 <a:cs typeface="Helvetica Neue"/>
               </a:rPr>
-              <a:t>ПОЧЕМУ МЫ</a:t>
+              <a:t>УСЛОВИЯ ПОКАЗА</a:t>
             </a:r>
           </a:p>
         </p:txBody>
@@ -5538,6 +5748,7 @@
           <a:lstStyle xmlns:a="http://schemas.openxmlformats.org/drawingml/2006/main"/>
           <a:p xmlns:a="http://schemas.openxmlformats.org/drawingml/2006/main">
             <a:pPr>
+              <a:buNone/>
               <a:defRPr sz="6150" b="1">
                 <a:solidFill>
                   <a:srgbClr val="000000"/>
@@ -5556,7 +5767,7 @@
                 <a:ea typeface="Helvetica Neue"/>
                 <a:cs typeface="Helvetica Neue"/>
               </a:rPr>
-              <a:t>По рукам?</a:t>
+              <a:t>Следующий шаг</a:t>
             </a:r>
           </a:p>
         </p:txBody>
@@ -5594,6 +5805,7 @@
           <a:lstStyle xmlns:a="http://schemas.openxmlformats.org/drawingml/2006/main"/>
           <a:p xmlns:a="http://schemas.openxmlformats.org/drawingml/2006/main">
             <a:pPr>
+              <a:buNone/>
               <a:defRPr sz="1875" b="0">
                 <a:solidFill>
                   <a:srgbClr val="000000"/>
@@ -5612,7 +5824,7 @@
                 <a:ea typeface="Helvetica Neue"/>
                 <a:cs typeface="Helvetica Neue"/>
               </a:rPr>
-              <a:t>Новый рынок: карточки спроса</a:t>
+              <a:t>Микрофон и HTTPS на втором устройстве</a:t>
             </a:r>
           </a:p>
         </p:txBody>
@@ -5650,6 +5862,7 @@
           <a:lstStyle xmlns:a="http://schemas.openxmlformats.org/drawingml/2006/main"/>
           <a:p xmlns:a="http://schemas.openxmlformats.org/drawingml/2006/main">
             <a:pPr>
+              <a:buNone/>
               <a:defRPr sz="1875" b="0">
                 <a:solidFill>
                   <a:srgbClr val="000000"/>
@@ -5668,7 +5881,7 @@
                 <a:ea typeface="Helvetica Neue"/>
                 <a:cs typeface="Helvetica Neue"/>
               </a:rPr>
-              <a:t>Доступный малый опт через коалиции</a:t>
+              <a:t>Финальный показ и видео требуют проверки</a:t>
             </a:r>
           </a:p>
         </p:txBody>
@@ -5706,6 +5919,7 @@
           <a:lstStyle xmlns:a="http://schemas.openxmlformats.org/drawingml/2006/main"/>
           <a:p xmlns:a="http://schemas.openxmlformats.org/drawingml/2006/main">
             <a:pPr>
+              <a:buNone/>
               <a:defRPr sz="1875" b="1">
                 <a:solidFill>
                   <a:srgbClr val="000000"/>
@@ -5724,7 +5938,7 @@
                 <a:ea typeface="Helvetica Neue"/>
                 <a:cs typeface="Helvetica Neue"/>
               </a:rPr>
-              <a:t>ИИ предлагает — человек решает</a:t>
+              <a:t>Каждый критерий требует своих доказательств</a:t>
             </a:r>
           </a:p>
         </p:txBody>

</xml_diff>